<commit_message>
Deploy ShadeShift on Firebase with private workspaces and verified end-to-end flows
</commit_message>
<xml_diff>
--- a/submission/pitch/ShadeShift-Pitch.pptx
+++ b/submission/pitch/ShadeShift-Pitch.pptx
@@ -2,20 +2,20 @@
 <file path=ppt/presentation.xml><?xml version="1.0" encoding="utf-8"?>
 <p:presentation xmlns:p="http://schemas.openxmlformats.org/presentationml/2006/main">
   <p:sldMasterIdLst>
-    <p:sldMasterId xmlns:r="http://schemas.openxmlformats.org/officeDocument/2006/relationships" id="2147483648" r:id="R2144d84191274f10"/>
+    <p:sldMasterId xmlns:r="http://schemas.openxmlformats.org/officeDocument/2006/relationships" id="2147483648" r:id="R9e98a77192d4442f"/>
   </p:sldMasterIdLst>
   <p:notesMasterIdLst>
-    <p:notesMasterId xmlns:r="http://schemas.openxmlformats.org/officeDocument/2006/relationships" r:id="Re58a53c3b0c54ed4"/>
+    <p:notesMasterId xmlns:r="http://schemas.openxmlformats.org/officeDocument/2006/relationships" r:id="Rd25020c666cf4ad5"/>
   </p:notesMasterIdLst>
   <p:sldIdLst>
-    <p:sldId xmlns:r="http://schemas.openxmlformats.org/officeDocument/2006/relationships" id="256" r:id="Rbca740d1a4fc4f6e"/>
-    <p:sldId xmlns:r="http://schemas.openxmlformats.org/officeDocument/2006/relationships" id="257" r:id="R99f64e4c43fa4ac4"/>
-    <p:sldId xmlns:r="http://schemas.openxmlformats.org/officeDocument/2006/relationships" id="258" r:id="R7b1b822083c64efd"/>
-    <p:sldId xmlns:r="http://schemas.openxmlformats.org/officeDocument/2006/relationships" id="259" r:id="Rf273a16b051f4cd4"/>
-    <p:sldId xmlns:r="http://schemas.openxmlformats.org/officeDocument/2006/relationships" id="260" r:id="R2a1500c017a64f21"/>
-    <p:sldId xmlns:r="http://schemas.openxmlformats.org/officeDocument/2006/relationships" id="261" r:id="R8db27d0a52454b7b"/>
-    <p:sldId xmlns:r="http://schemas.openxmlformats.org/officeDocument/2006/relationships" id="262" r:id="Rdb9373bb76dd4087"/>
-    <p:sldId xmlns:r="http://schemas.openxmlformats.org/officeDocument/2006/relationships" id="263" r:id="Rb3f1f9f942f9472a"/>
+    <p:sldId xmlns:r="http://schemas.openxmlformats.org/officeDocument/2006/relationships" id="256" r:id="Re251743d51c248f9"/>
+    <p:sldId xmlns:r="http://schemas.openxmlformats.org/officeDocument/2006/relationships" id="257" r:id="R9d7a8d5acc794dcf"/>
+    <p:sldId xmlns:r="http://schemas.openxmlformats.org/officeDocument/2006/relationships" id="258" r:id="R117003ece3dc4cfe"/>
+    <p:sldId xmlns:r="http://schemas.openxmlformats.org/officeDocument/2006/relationships" id="259" r:id="R190c667109d649ff"/>
+    <p:sldId xmlns:r="http://schemas.openxmlformats.org/officeDocument/2006/relationships" id="260" r:id="R7254cd64fc7c4354"/>
+    <p:sldId xmlns:r="http://schemas.openxmlformats.org/officeDocument/2006/relationships" id="261" r:id="R7af0f2414e124b38"/>
+    <p:sldId xmlns:r="http://schemas.openxmlformats.org/officeDocument/2006/relationships" id="262" r:id="R5cd497fdbbf44253"/>
+    <p:sldId xmlns:r="http://schemas.openxmlformats.org/officeDocument/2006/relationships" id="263" r:id="R13e52c536c134a86"/>
   </p:sldIdLst>
   <p:sldSz cx="12192000" cy="6858000"/>
   <p:notesSz cx="6858000" cy="9144000"/>
@@ -519,7 +519,7 @@
           <a:lstStyle xmlns:a="http://schemas.openxmlformats.org/drawingml/2006/main"/>
           <a:p xmlns:a="http://schemas.openxmlformats.org/drawingml/2006/main">
             <a:r>
-              <a:t>Actual application screenshot. First buyer hypothesis: a venue or event operator. The $70,000 is selected intervention spend in the demonstration, with a $75,000 cap. This is separate from software pricing. Approximate candidate connectors are not navigation instructions. Colored historical temperature points date to August 7 2020, not the event date. OpenStreetMap basemap attribution remains visible. Sources: https://www.openstreetmap.org/copyright and https://www.arcgis.com/home/item.html?id=d8dd6004e1ab4dccbfb36a5992f480bc . Users can explore without signing in, then use ChatGPT authentication for private saved plans in D1.</a:t>
+              <a:t>Actual application screenshot. First buyer hypothesis: a venue or event operator. The $70,000 is selected intervention spend in the demonstration, with a $75,000 cap. This is separate from software pricing. Approximate candidate connectors are not navigation instructions. Colored historical temperature points date to August 7 2020, not the event date. OpenStreetMap basemap attribution remains visible. Sources: https://www.openstreetmap.org/copyright and https://www.arcgis.com/home/item.html?id=d8dd6004e1ab4dccbfb36a5992f480bc . Users can explore without signing in, then use Firebase Authentication with email and password for private plans stored in Cloud Firestore with owner-scoped security rules.</a:t>
             </a:r>
           </a:p>
         </p:txBody>
@@ -939,7 +939,7 @@
           <a:lstStyle xmlns:a="http://schemas.openxmlformats.org/drawingml/2006/main"/>
           <a:p xmlns:a="http://schemas.openxmlformats.org/drawingml/2006/main">
             <a:r>
-              <a:t>Close with a concrete ask: one venue partner for two events, with site access, operator counts, a venue operations contact and an accessibility review. No outreach or partner commitment is implied. The product turns a heat map into a reviewable funded shade plan. Open the supplied project link for the interactive demonstration. Anonymous judging copy.</a:t>
+              <a:t>Close with a concrete ask: one venue partner for two events, with site access, operator counts, a venue operations contact and an accessibility review. No outreach or partner commitment is implied. The product turns a heat map into a reviewable funded shade plan. Live demonstration: https://shadeshift-city.web.app . Source repository: https://github.com/shi1720/shadeshift . Built with Vite, React, TypeScript, Leaflet and Recharts, hosted on Firebase Hosting with Firebase Authentication and Cloud Firestore. Anonymous judging copy.</a:t>
             </a:r>
           </a:p>
         </p:txBody>
@@ -1007,7 +1007,7 @@
   </p:cSld>
   <p:clrMap bg1="lt1" tx1="dk1" bg2="lt2" tx2="dk2" accent1="accent1" accent2="accent2" accent3="accent3" accent4="accent4" accent5="accent5" accent6="accent6" hlink="hlink" folHlink="folHlink"/>
   <p:sldLayoutIdLst>
-    <p:sldLayoutId xmlns:r="http://schemas.openxmlformats.org/officeDocument/2006/relationships" id="2147483649" r:id="R32afdf4c72914c50"/>
+    <p:sldLayoutId xmlns:r="http://schemas.openxmlformats.org/officeDocument/2006/relationships" id="2147483649" r:id="R0b592e669a0a45b4"/>
   </p:sldLayoutIdLst>
   <p:txStyles>
     <p:titleStyle>
@@ -1946,7 +1946,7 @@
           <p:cNvPr id="6" name="">
             <a:extLst xmlns:a="http://schemas.openxmlformats.org/drawingml/2006/main">
               <a:ext uri="{FF2B5EF4-FFF2-40B4-BE49-F238E27FC236}">
-                <a16:creationId xmlns:a16="http://schemas.microsoft.com/office/drawing/2014/main" id="{59775804-E2CF-4A32-B6DD-C67264E06BAF}"/>
+                <a16:creationId xmlns:a16="http://schemas.microsoft.com/office/drawing/2014/main" id="{BE83239F-3D77-4EB4-9346-FF3A28A8CA82}"/>
               </a:ext>
             </a:extLst>
           </p:cNvPr>
@@ -2003,7 +2003,7 @@
           <p:cNvPr id="2" name="">
             <a:extLst xmlns:a="http://schemas.openxmlformats.org/drawingml/2006/main">
               <a:ext uri="{FF2B5EF4-FFF2-40B4-BE49-F238E27FC236}">
-                <a16:creationId xmlns:a16="http://schemas.microsoft.com/office/drawing/2014/main" id="{924E199E-D993-4310-A144-9AF6C336C061}"/>
+                <a16:creationId xmlns:a16="http://schemas.microsoft.com/office/drawing/2014/main" id="{CAD06308-71B3-4585-9DDB-DE26AA4198FE}"/>
               </a:ext>
             </a:extLst>
           </p:cNvPr>
@@ -2060,7 +2060,7 @@
           <p:cNvPr id="3" name="">
             <a:extLst xmlns:a="http://schemas.openxmlformats.org/drawingml/2006/main">
               <a:ext uri="{FF2B5EF4-FFF2-40B4-BE49-F238E27FC236}">
-                <a16:creationId xmlns:a16="http://schemas.microsoft.com/office/drawing/2014/main" id="{207FB8B6-12FB-4C06-B39D-3224C3136D23}"/>
+                <a16:creationId xmlns:a16="http://schemas.microsoft.com/office/drawing/2014/main" id="{2F01B93C-632B-4939-BD26-CF43B613B099}"/>
               </a:ext>
             </a:extLst>
           </p:cNvPr>
@@ -2117,7 +2117,7 @@
           <p:cNvPr id="4" name="">
             <a:extLst xmlns:a="http://schemas.openxmlformats.org/drawingml/2006/main">
               <a:ext uri="{FF2B5EF4-FFF2-40B4-BE49-F238E27FC236}">
-                <a16:creationId xmlns:a16="http://schemas.microsoft.com/office/drawing/2014/main" id="{339404FE-B7F2-4C9B-B6DD-07AB65700F95}"/>
+                <a16:creationId xmlns:a16="http://schemas.microsoft.com/office/drawing/2014/main" id="{086467F4-7C34-4BC6-867F-3EFBE696549F}"/>
               </a:ext>
             </a:extLst>
           </p:cNvPr>
@@ -2197,7 +2197,7 @@
           <p:cNvPr id="5" name="">
             <a:extLst xmlns:a="http://schemas.openxmlformats.org/drawingml/2006/main">
               <a:ext uri="{FF2B5EF4-FFF2-40B4-BE49-F238E27FC236}">
-                <a16:creationId xmlns:a16="http://schemas.microsoft.com/office/drawing/2014/main" id="{8F7421F1-B0D6-4E2B-B8A8-4FEB8D737010}"/>
+                <a16:creationId xmlns:a16="http://schemas.microsoft.com/office/drawing/2014/main" id="{E88E326A-9A30-436B-B3FC-AD16E116A949}"/>
               </a:ext>
             </a:extLst>
           </p:cNvPr>
@@ -2275,7 +2275,7 @@
     </p:spTree>
     <p:extLst>
       <p:ext uri="{BB962C8B-B14F-4D97-AF65-F5344CB8AC3E}">
-        <p14:creationId xmlns:p14="http://schemas.microsoft.com/office/powerpoint/2010/main" val="1487491287"/>
+        <p14:creationId xmlns:p14="http://schemas.microsoft.com/office/powerpoint/2010/main" val="1011430481"/>
       </p:ext>
     </p:extLst>
   </p:cSld>
@@ -2306,7 +2306,7 @@
           <p:cNvPr id="8" name="">
             <a:extLst xmlns:a="http://schemas.openxmlformats.org/drawingml/2006/main">
               <a:ext uri="{FF2B5EF4-FFF2-40B4-BE49-F238E27FC236}">
-                <a16:creationId xmlns:a16="http://schemas.microsoft.com/office/drawing/2014/main" id="{DD749D5B-3E9C-41D0-BB92-7BFBC12056AF}"/>
+                <a16:creationId xmlns:a16="http://schemas.microsoft.com/office/drawing/2014/main" id="{422E835D-1D9D-4AA9-BD93-4818C111E4D4}"/>
               </a:ext>
             </a:extLst>
           </p:cNvPr>
@@ -2363,7 +2363,7 @@
           <p:cNvPr id="2" name="">
             <a:extLst xmlns:a="http://schemas.openxmlformats.org/drawingml/2006/main">
               <a:ext uri="{FF2B5EF4-FFF2-40B4-BE49-F238E27FC236}">
-                <a16:creationId xmlns:a16="http://schemas.microsoft.com/office/drawing/2014/main" id="{58A811E8-12E3-42FB-8107-3BB960F18278}"/>
+                <a16:creationId xmlns:a16="http://schemas.microsoft.com/office/drawing/2014/main" id="{B8E5EFB9-29E5-489F-9DC8-34A1B1DA36BD}"/>
               </a:ext>
             </a:extLst>
           </p:cNvPr>
@@ -2420,7 +2420,7 @@
           <p:cNvPr id="3" name="">
             <a:extLst xmlns:a="http://schemas.openxmlformats.org/drawingml/2006/main">
               <a:ext uri="{FF2B5EF4-FFF2-40B4-BE49-F238E27FC236}">
-                <a16:creationId xmlns:a16="http://schemas.microsoft.com/office/drawing/2014/main" id="{1AEBBED2-7188-46BC-BB98-F9312264F566}"/>
+                <a16:creationId xmlns:a16="http://schemas.microsoft.com/office/drawing/2014/main" id="{B38B0152-7776-4F00-9C5C-8F23CCD299D5}"/>
               </a:ext>
             </a:extLst>
           </p:cNvPr>
@@ -2477,7 +2477,7 @@
           <p:cNvPr id="4" name="">
             <a:extLst xmlns:a="http://schemas.openxmlformats.org/drawingml/2006/main">
               <a:ext uri="{FF2B5EF4-FFF2-40B4-BE49-F238E27FC236}">
-                <a16:creationId xmlns:a16="http://schemas.microsoft.com/office/drawing/2014/main" id="{9252D1CB-783F-4959-BBF4-C6388072313E}"/>
+                <a16:creationId xmlns:a16="http://schemas.microsoft.com/office/drawing/2014/main" id="{ED391101-01B3-4B83-828B-08F8B39F5663}"/>
               </a:ext>
             </a:extLst>
           </p:cNvPr>
@@ -2557,7 +2557,7 @@
           <p:cNvPr id="5" name="">
             <a:extLst xmlns:a="http://schemas.openxmlformats.org/drawingml/2006/main">
               <a:ext uri="{FF2B5EF4-FFF2-40B4-BE49-F238E27FC236}">
-                <a16:creationId xmlns:a16="http://schemas.microsoft.com/office/drawing/2014/main" id="{C54F1461-995E-4AE7-88E2-2BFFCD426406}"/>
+                <a16:creationId xmlns:a16="http://schemas.microsoft.com/office/drawing/2014/main" id="{A2B1F1FE-0CA2-4174-9B28-E94FB87D7A29}"/>
               </a:ext>
             </a:extLst>
           </p:cNvPr>
@@ -2637,7 +2637,7 @@
           <p:cNvPr id="6" name="">
             <a:extLst xmlns:a="http://schemas.openxmlformats.org/drawingml/2006/main">
               <a:ext uri="{FF2B5EF4-FFF2-40B4-BE49-F238E27FC236}">
-                <a16:creationId xmlns:a16="http://schemas.microsoft.com/office/drawing/2014/main" id="{A66E6E82-78CE-49BD-AF81-3FC8D15FF16F}"/>
+                <a16:creationId xmlns:a16="http://schemas.microsoft.com/office/drawing/2014/main" id="{67F228E5-F8AB-45C0-9C47-89E38680B75F}"/>
               </a:ext>
             </a:extLst>
           </p:cNvPr>
@@ -2721,7 +2721,7 @@
           <p:nvPr/>
         </p:nvPicPr>
         <p:blipFill>
-          <a:blip xmlns:r="http://schemas.openxmlformats.org/officeDocument/2006/relationships" xmlns:a="http://schemas.openxmlformats.org/drawingml/2006/main" r:embed="R3ef8fd4d2daa41ba"/>
+          <a:blip xmlns:r="http://schemas.openxmlformats.org/officeDocument/2006/relationships" xmlns:a="http://schemas.openxmlformats.org/drawingml/2006/main" r:embed="R3a0ee8c44b7d4558"/>
           <a:srcRect xmlns:a="http://schemas.openxmlformats.org/drawingml/2006/main" l="0" t="10406" r="0" b="10406"/>
           <a:stretch xmlns:a="http://schemas.openxmlformats.org/drawingml/2006/main">
             <a:fillRect l="0" t="0" r="0" b="0"/>
@@ -2740,7 +2740,7 @@
     </p:spTree>
     <p:extLst>
       <p:ext uri="{BB962C8B-B14F-4D97-AF65-F5344CB8AC3E}">
-        <p14:creationId xmlns:p14="http://schemas.microsoft.com/office/powerpoint/2010/main" val="823095943"/>
+        <p14:creationId xmlns:p14="http://schemas.microsoft.com/office/powerpoint/2010/main" val="1166331079"/>
       </p:ext>
     </p:extLst>
   </p:cSld>
@@ -2771,7 +2771,7 @@
           <p:cNvPr id="11" name="">
             <a:extLst xmlns:a="http://schemas.openxmlformats.org/drawingml/2006/main">
               <a:ext uri="{FF2B5EF4-FFF2-40B4-BE49-F238E27FC236}">
-                <a16:creationId xmlns:a16="http://schemas.microsoft.com/office/drawing/2014/main" id="{FCD2855D-C29A-4DF1-8363-EECBDD25130D}"/>
+                <a16:creationId xmlns:a16="http://schemas.microsoft.com/office/drawing/2014/main" id="{B2A28C45-6A8B-49D6-BB7F-A384D6D0D03E}"/>
               </a:ext>
             </a:extLst>
           </p:cNvPr>
@@ -2828,7 +2828,7 @@
           <p:cNvPr id="2" name="">
             <a:extLst xmlns:a="http://schemas.openxmlformats.org/drawingml/2006/main">
               <a:ext uri="{FF2B5EF4-FFF2-40B4-BE49-F238E27FC236}">
-                <a16:creationId xmlns:a16="http://schemas.microsoft.com/office/drawing/2014/main" id="{71E071B6-286F-45FF-A9F2-223FE9D92C00}"/>
+                <a16:creationId xmlns:a16="http://schemas.microsoft.com/office/drawing/2014/main" id="{1248D6C5-1F7A-48C8-8C7F-46B810A51D3D}"/>
               </a:ext>
             </a:extLst>
           </p:cNvPr>
@@ -2885,7 +2885,7 @@
           <p:cNvPr id="3" name="">
             <a:extLst xmlns:a="http://schemas.openxmlformats.org/drawingml/2006/main">
               <a:ext uri="{FF2B5EF4-FFF2-40B4-BE49-F238E27FC236}">
-                <a16:creationId xmlns:a16="http://schemas.microsoft.com/office/drawing/2014/main" id="{D6E54D0F-3F86-4F09-AE72-20481C1E5B96}"/>
+                <a16:creationId xmlns:a16="http://schemas.microsoft.com/office/drawing/2014/main" id="{89922643-AB72-47B4-A786-C30C5F3567DF}"/>
               </a:ext>
             </a:extLst>
           </p:cNvPr>
@@ -2942,7 +2942,7 @@
           <p:cNvPr id="4" name="">
             <a:extLst xmlns:a="http://schemas.openxmlformats.org/drawingml/2006/main">
               <a:ext uri="{FF2B5EF4-FFF2-40B4-BE49-F238E27FC236}">
-                <a16:creationId xmlns:a16="http://schemas.microsoft.com/office/drawing/2014/main" id="{97127653-9E1C-4163-95D7-323721A3C722}"/>
+                <a16:creationId xmlns:a16="http://schemas.microsoft.com/office/drawing/2014/main" id="{7BA6844F-4C80-4A3F-9FA5-2A7BB4D57291}"/>
               </a:ext>
             </a:extLst>
           </p:cNvPr>
@@ -2999,7 +2999,7 @@
           <p:cNvPr id="5" name="">
             <a:extLst xmlns:a="http://schemas.openxmlformats.org/drawingml/2006/main">
               <a:ext uri="{FF2B5EF4-FFF2-40B4-BE49-F238E27FC236}">
-                <a16:creationId xmlns:a16="http://schemas.microsoft.com/office/drawing/2014/main" id="{8E499322-CF2A-4D1B-A82D-E527AFCD94DA}"/>
+                <a16:creationId xmlns:a16="http://schemas.microsoft.com/office/drawing/2014/main" id="{29F73C23-477A-4578-9CA6-E71500733031}"/>
               </a:ext>
             </a:extLst>
           </p:cNvPr>
@@ -3056,7 +3056,7 @@
           <p:cNvPr id="6" name="">
             <a:extLst xmlns:a="http://schemas.openxmlformats.org/drawingml/2006/main">
               <a:ext uri="{FF2B5EF4-FFF2-40B4-BE49-F238E27FC236}">
-                <a16:creationId xmlns:a16="http://schemas.microsoft.com/office/drawing/2014/main" id="{82321D5B-1ACB-4D68-A857-7ADD91F73A4E}"/>
+                <a16:creationId xmlns:a16="http://schemas.microsoft.com/office/drawing/2014/main" id="{837862F3-9DA0-4347-A9DF-F723653D02D6}"/>
               </a:ext>
             </a:extLst>
           </p:cNvPr>
@@ -3159,7 +3159,7 @@
           <p:cNvPr id="7" name="">
             <a:extLst xmlns:a="http://schemas.openxmlformats.org/drawingml/2006/main">
               <a:ext uri="{FF2B5EF4-FFF2-40B4-BE49-F238E27FC236}">
-                <a16:creationId xmlns:a16="http://schemas.microsoft.com/office/drawing/2014/main" id="{ABBF3EC9-AD4C-46C1-BA3F-0333ABC6197A}"/>
+                <a16:creationId xmlns:a16="http://schemas.microsoft.com/office/drawing/2014/main" id="{8669CEA3-3494-45A5-B3AA-9A7F2EDFC172}"/>
               </a:ext>
             </a:extLst>
           </p:cNvPr>
@@ -3216,7 +3216,7 @@
           <p:cNvPr id="8" name="">
             <a:extLst xmlns:a="http://schemas.openxmlformats.org/drawingml/2006/main">
               <a:ext uri="{FF2B5EF4-FFF2-40B4-BE49-F238E27FC236}">
-                <a16:creationId xmlns:a16="http://schemas.microsoft.com/office/drawing/2014/main" id="{AB913288-4046-4289-8D72-C2CD15D26D2A}"/>
+                <a16:creationId xmlns:a16="http://schemas.microsoft.com/office/drawing/2014/main" id="{8999511F-C3D6-48B4-B178-397EB152965E}"/>
               </a:ext>
             </a:extLst>
           </p:cNvPr>
@@ -3273,7 +3273,7 @@
           <p:cNvPr id="9" name="">
             <a:extLst xmlns:a="http://schemas.openxmlformats.org/drawingml/2006/main">
               <a:ext uri="{FF2B5EF4-FFF2-40B4-BE49-F238E27FC236}">
-                <a16:creationId xmlns:a16="http://schemas.microsoft.com/office/drawing/2014/main" id="{07EDF35A-4D5D-41E6-B200-98356390BD97}"/>
+                <a16:creationId xmlns:a16="http://schemas.microsoft.com/office/drawing/2014/main" id="{1A06A5CD-B7EC-4C8F-99E4-9AF82F4E8BD7}"/>
               </a:ext>
             </a:extLst>
           </p:cNvPr>
@@ -3376,7 +3376,7 @@
           <p:cNvPr id="10" name="">
             <a:extLst xmlns:a="http://schemas.openxmlformats.org/drawingml/2006/main">
               <a:ext uri="{FF2B5EF4-FFF2-40B4-BE49-F238E27FC236}">
-                <a16:creationId xmlns:a16="http://schemas.microsoft.com/office/drawing/2014/main" id="{ABDDCF02-2004-4D56-9FEB-C04E7D90569A}"/>
+                <a16:creationId xmlns:a16="http://schemas.microsoft.com/office/drawing/2014/main" id="{CAF60E1B-0A12-4FE2-B165-F3F3E0492282}"/>
               </a:ext>
             </a:extLst>
           </p:cNvPr>
@@ -3431,7 +3431,7 @@
     </p:spTree>
     <p:extLst>
       <p:ext uri="{BB962C8B-B14F-4D97-AF65-F5344CB8AC3E}">
-        <p14:creationId xmlns:p14="http://schemas.microsoft.com/office/powerpoint/2010/main" val="414914530"/>
+        <p14:creationId xmlns:p14="http://schemas.microsoft.com/office/powerpoint/2010/main" val="1978246935"/>
       </p:ext>
     </p:extLst>
   </p:cSld>
@@ -3462,7 +3462,7 @@
           <p:cNvPr id="10" name="">
             <a:extLst xmlns:a="http://schemas.openxmlformats.org/drawingml/2006/main">
               <a:ext uri="{FF2B5EF4-FFF2-40B4-BE49-F238E27FC236}">
-                <a16:creationId xmlns:a16="http://schemas.microsoft.com/office/drawing/2014/main" id="{6841B027-A123-4C46-98A0-FBC79E82D8CF}"/>
+                <a16:creationId xmlns:a16="http://schemas.microsoft.com/office/drawing/2014/main" id="{C01A5C1B-AAA8-40EF-8C65-D284E1C0BB17}"/>
               </a:ext>
             </a:extLst>
           </p:cNvPr>
@@ -3519,7 +3519,7 @@
           <p:cNvPr id="2" name="">
             <a:extLst xmlns:a="http://schemas.openxmlformats.org/drawingml/2006/main">
               <a:ext uri="{FF2B5EF4-FFF2-40B4-BE49-F238E27FC236}">
-                <a16:creationId xmlns:a16="http://schemas.microsoft.com/office/drawing/2014/main" id="{EA659016-E099-4E44-ACBA-C979B73480FE}"/>
+                <a16:creationId xmlns:a16="http://schemas.microsoft.com/office/drawing/2014/main" id="{A44387A4-040F-49E9-81DF-9300FEEB0B45}"/>
               </a:ext>
             </a:extLst>
           </p:cNvPr>
@@ -3576,7 +3576,7 @@
           <p:cNvPr id="3" name="">
             <a:extLst xmlns:a="http://schemas.openxmlformats.org/drawingml/2006/main">
               <a:ext uri="{FF2B5EF4-FFF2-40B4-BE49-F238E27FC236}">
-                <a16:creationId xmlns:a16="http://schemas.microsoft.com/office/drawing/2014/main" id="{1B6B9729-CA89-478F-9B14-4786FC6EF75B}"/>
+                <a16:creationId xmlns:a16="http://schemas.microsoft.com/office/drawing/2014/main" id="{693774CB-4CF8-4A2C-AAE7-0B5736CF57AD}"/>
               </a:ext>
             </a:extLst>
           </p:cNvPr>
@@ -3633,7 +3633,7 @@
           <p:cNvPr id="4" name="">
             <a:extLst xmlns:a="http://schemas.openxmlformats.org/drawingml/2006/main">
               <a:ext uri="{FF2B5EF4-FFF2-40B4-BE49-F238E27FC236}">
-                <a16:creationId xmlns:a16="http://schemas.microsoft.com/office/drawing/2014/main" id="{3A910996-A1FF-4779-9B99-15406E10F9DC}"/>
+                <a16:creationId xmlns:a16="http://schemas.microsoft.com/office/drawing/2014/main" id="{B370B319-09B3-4B24-89EF-F71C56423FD4}"/>
               </a:ext>
             </a:extLst>
           </p:cNvPr>
@@ -3690,7 +3690,7 @@
           <p:cNvPr id="5" name="">
             <a:extLst xmlns:a="http://schemas.openxmlformats.org/drawingml/2006/main">
               <a:ext uri="{FF2B5EF4-FFF2-40B4-BE49-F238E27FC236}">
-                <a16:creationId xmlns:a16="http://schemas.microsoft.com/office/drawing/2014/main" id="{D1FA65C3-064F-41DC-8382-497D84011BD1}"/>
+                <a16:creationId xmlns:a16="http://schemas.microsoft.com/office/drawing/2014/main" id="{8EBBF1C5-6496-4BC8-8B87-37F22D430836}"/>
               </a:ext>
             </a:extLst>
           </p:cNvPr>
@@ -3770,7 +3770,7 @@
           <p:cNvPr id="6" name="">
             <a:extLst xmlns:a="http://schemas.openxmlformats.org/drawingml/2006/main">
               <a:ext uri="{FF2B5EF4-FFF2-40B4-BE49-F238E27FC236}">
-                <a16:creationId xmlns:a16="http://schemas.microsoft.com/office/drawing/2014/main" id="{96408DF6-4F04-4C11-8F72-BE4FDC2D1D53}"/>
+                <a16:creationId xmlns:a16="http://schemas.microsoft.com/office/drawing/2014/main" id="{0A24EFAE-6257-4CE8-9E0B-72EE0C20B44C}"/>
               </a:ext>
             </a:extLst>
           </p:cNvPr>
@@ -3850,7 +3850,7 @@
           <p:cNvPr id="7" name="">
             <a:extLst xmlns:a="http://schemas.openxmlformats.org/drawingml/2006/main">
               <a:ext uri="{FF2B5EF4-FFF2-40B4-BE49-F238E27FC236}">
-                <a16:creationId xmlns:a16="http://schemas.microsoft.com/office/drawing/2014/main" id="{3A614A9A-555D-4BFF-98C0-65F9AD7C09CA}"/>
+                <a16:creationId xmlns:a16="http://schemas.microsoft.com/office/drawing/2014/main" id="{0B8F0A96-0200-4F83-A8D1-6DB656A8148E}"/>
               </a:ext>
             </a:extLst>
           </p:cNvPr>
@@ -3937,7 +3937,7 @@
         </p:xfrm>
         <a:graphic xmlns:a="http://schemas.openxmlformats.org/drawingml/2006/main">
           <a:graphicData uri="http://schemas.openxmlformats.org/drawingml/2006/chart">
-            <c:chart xmlns:r="http://schemas.openxmlformats.org/officeDocument/2006/relationships" xmlns:c="http://schemas.openxmlformats.org/drawingml/2006/chart" r:id="R289e622370b041cc"/>
+            <c:chart xmlns:r="http://schemas.openxmlformats.org/officeDocument/2006/relationships" xmlns:c="http://schemas.openxmlformats.org/drawingml/2006/chart" r:id="R4696e18119ba4d8e"/>
           </a:graphicData>
         </a:graphic>
       </p:graphicFrame>
@@ -3946,7 +3946,7 @@
           <p:cNvPr id="9" name="">
             <a:extLst xmlns:a="http://schemas.openxmlformats.org/drawingml/2006/main">
               <a:ext uri="{FF2B5EF4-FFF2-40B4-BE49-F238E27FC236}">
-                <a16:creationId xmlns:a16="http://schemas.microsoft.com/office/drawing/2014/main" id="{881C0F51-CA7B-4C86-B2CA-A280AE44D20B}"/>
+                <a16:creationId xmlns:a16="http://schemas.microsoft.com/office/drawing/2014/main" id="{D1EAB6E0-F9AD-42D8-8B89-3ADD3C94FA2E}"/>
               </a:ext>
             </a:extLst>
           </p:cNvPr>
@@ -4001,7 +4001,7 @@
     </p:spTree>
     <p:extLst>
       <p:ext uri="{BB962C8B-B14F-4D97-AF65-F5344CB8AC3E}">
-        <p14:creationId xmlns:p14="http://schemas.microsoft.com/office/powerpoint/2010/main" val="1596989420"/>
+        <p14:creationId xmlns:p14="http://schemas.microsoft.com/office/powerpoint/2010/main" val="964541969"/>
       </p:ext>
     </p:extLst>
   </p:cSld>
@@ -4032,7 +4032,7 @@
           <p:cNvPr id="11" name="">
             <a:extLst xmlns:a="http://schemas.openxmlformats.org/drawingml/2006/main">
               <a:ext uri="{FF2B5EF4-FFF2-40B4-BE49-F238E27FC236}">
-                <a16:creationId xmlns:a16="http://schemas.microsoft.com/office/drawing/2014/main" id="{C4F7F470-141F-4686-831C-FC7081E31D5B}"/>
+                <a16:creationId xmlns:a16="http://schemas.microsoft.com/office/drawing/2014/main" id="{7572AF67-0262-4757-8489-669842B22415}"/>
               </a:ext>
             </a:extLst>
           </p:cNvPr>
@@ -4089,7 +4089,7 @@
           <p:cNvPr id="2" name="">
             <a:extLst xmlns:a="http://schemas.openxmlformats.org/drawingml/2006/main">
               <a:ext uri="{FF2B5EF4-FFF2-40B4-BE49-F238E27FC236}">
-                <a16:creationId xmlns:a16="http://schemas.microsoft.com/office/drawing/2014/main" id="{9C314027-7FD8-43DA-AA27-F71FBF63F062}"/>
+                <a16:creationId xmlns:a16="http://schemas.microsoft.com/office/drawing/2014/main" id="{241E689C-F6DB-41EB-96FD-7F26D6EEBD3D}"/>
               </a:ext>
             </a:extLst>
           </p:cNvPr>
@@ -4146,7 +4146,7 @@
           <p:cNvPr id="3" name="">
             <a:extLst xmlns:a="http://schemas.openxmlformats.org/drawingml/2006/main">
               <a:ext uri="{FF2B5EF4-FFF2-40B4-BE49-F238E27FC236}">
-                <a16:creationId xmlns:a16="http://schemas.microsoft.com/office/drawing/2014/main" id="{04153DFC-7452-4600-91BF-176781ABD951}"/>
+                <a16:creationId xmlns:a16="http://schemas.microsoft.com/office/drawing/2014/main" id="{40469C12-C4F5-41E6-91E4-08FCB380CC20}"/>
               </a:ext>
             </a:extLst>
           </p:cNvPr>
@@ -4210,7 +4210,7 @@
         </p:xfrm>
         <a:graphic xmlns:a="http://schemas.openxmlformats.org/drawingml/2006/main">
           <a:graphicData uri="http://schemas.openxmlformats.org/drawingml/2006/chart">
-            <c:chart xmlns:r="http://schemas.openxmlformats.org/officeDocument/2006/relationships" xmlns:c="http://schemas.openxmlformats.org/drawingml/2006/chart" r:id="R9b11accf85ba4247"/>
+            <c:chart xmlns:r="http://schemas.openxmlformats.org/officeDocument/2006/relationships" xmlns:c="http://schemas.openxmlformats.org/drawingml/2006/chart" r:id="R1a7b2f65a6be49b7"/>
           </a:graphicData>
         </a:graphic>
       </p:graphicFrame>
@@ -4219,7 +4219,7 @@
           <p:cNvPr id="5" name="">
             <a:extLst xmlns:a="http://schemas.openxmlformats.org/drawingml/2006/main">
               <a:ext uri="{FF2B5EF4-FFF2-40B4-BE49-F238E27FC236}">
-                <a16:creationId xmlns:a16="http://schemas.microsoft.com/office/drawing/2014/main" id="{2299DD21-C67F-4025-BCA9-665D68C3C2D2}"/>
+                <a16:creationId xmlns:a16="http://schemas.microsoft.com/office/drawing/2014/main" id="{B25823A6-A5A4-4A36-BFF2-5E91F61C0FD1}"/>
               </a:ext>
             </a:extLst>
           </p:cNvPr>
@@ -4299,7 +4299,7 @@
           <p:cNvPr id="6" name="">
             <a:extLst xmlns:a="http://schemas.openxmlformats.org/drawingml/2006/main">
               <a:ext uri="{FF2B5EF4-FFF2-40B4-BE49-F238E27FC236}">
-                <a16:creationId xmlns:a16="http://schemas.microsoft.com/office/drawing/2014/main" id="{651B9C16-B019-406D-B5E0-9575873A556F}"/>
+                <a16:creationId xmlns:a16="http://schemas.microsoft.com/office/drawing/2014/main" id="{4BA55887-901C-4557-9FE7-95D11CAB39CE}"/>
               </a:ext>
             </a:extLst>
           </p:cNvPr>
@@ -4356,7 +4356,7 @@
           <p:cNvPr id="7" name="">
             <a:extLst xmlns:a="http://schemas.openxmlformats.org/drawingml/2006/main">
               <a:ext uri="{FF2B5EF4-FFF2-40B4-BE49-F238E27FC236}">
-                <a16:creationId xmlns:a16="http://schemas.microsoft.com/office/drawing/2014/main" id="{8AE0DAE9-EDA6-4136-ABCD-0C6D6BB44ACB}"/>
+                <a16:creationId xmlns:a16="http://schemas.microsoft.com/office/drawing/2014/main" id="{61E02674-A6F8-4BD5-8F65-E39CE8401EF4}"/>
               </a:ext>
             </a:extLst>
           </p:cNvPr>
@@ -4413,7 +4413,7 @@
           <p:cNvPr id="8" name="">
             <a:extLst xmlns:a="http://schemas.openxmlformats.org/drawingml/2006/main">
               <a:ext uri="{FF2B5EF4-FFF2-40B4-BE49-F238E27FC236}">
-                <a16:creationId xmlns:a16="http://schemas.microsoft.com/office/drawing/2014/main" id="{999CA8EF-5845-4A18-B472-C77EFF999256}"/>
+                <a16:creationId xmlns:a16="http://schemas.microsoft.com/office/drawing/2014/main" id="{353B0E97-9F17-4887-8ED5-0607EF35E53A}"/>
               </a:ext>
             </a:extLst>
           </p:cNvPr>
@@ -4470,7 +4470,7 @@
           <p:cNvPr id="9" name="">
             <a:extLst xmlns:a="http://schemas.openxmlformats.org/drawingml/2006/main">
               <a:ext uri="{FF2B5EF4-FFF2-40B4-BE49-F238E27FC236}">
-                <a16:creationId xmlns:a16="http://schemas.microsoft.com/office/drawing/2014/main" id="{1FD72D41-788B-4845-85EB-C86298FEAE60}"/>
+                <a16:creationId xmlns:a16="http://schemas.microsoft.com/office/drawing/2014/main" id="{875F2A24-85B7-4D78-94E8-F2E6E2B8F70E}"/>
               </a:ext>
             </a:extLst>
           </p:cNvPr>
@@ -4527,7 +4527,7 @@
           <p:cNvPr id="10" name="">
             <a:extLst xmlns:a="http://schemas.openxmlformats.org/drawingml/2006/main">
               <a:ext uri="{FF2B5EF4-FFF2-40B4-BE49-F238E27FC236}">
-                <a16:creationId xmlns:a16="http://schemas.microsoft.com/office/drawing/2014/main" id="{BBC0B049-F67D-4D29-B4F1-76EAE23D2DA2}"/>
+                <a16:creationId xmlns:a16="http://schemas.microsoft.com/office/drawing/2014/main" id="{F6E2D2E1-3292-4789-B72C-8C672EDFFCFB}"/>
               </a:ext>
             </a:extLst>
           </p:cNvPr>
@@ -4605,7 +4605,7 @@
     </p:spTree>
     <p:extLst>
       <p:ext uri="{BB962C8B-B14F-4D97-AF65-F5344CB8AC3E}">
-        <p14:creationId xmlns:p14="http://schemas.microsoft.com/office/powerpoint/2010/main" val="1642721356"/>
+        <p14:creationId xmlns:p14="http://schemas.microsoft.com/office/powerpoint/2010/main" val="26129818"/>
       </p:ext>
     </p:extLst>
   </p:cSld>
@@ -4636,7 +4636,7 @@
           <p:cNvPr id="11" name="">
             <a:extLst xmlns:a="http://schemas.openxmlformats.org/drawingml/2006/main">
               <a:ext uri="{FF2B5EF4-FFF2-40B4-BE49-F238E27FC236}">
-                <a16:creationId xmlns:a16="http://schemas.microsoft.com/office/drawing/2014/main" id="{74384093-3C69-4AAE-81D4-F9C33DF7409E}"/>
+                <a16:creationId xmlns:a16="http://schemas.microsoft.com/office/drawing/2014/main" id="{08137E54-FE92-405D-ACA7-78775591D206}"/>
               </a:ext>
             </a:extLst>
           </p:cNvPr>
@@ -4693,7 +4693,7 @@
           <p:cNvPr id="2" name="">
             <a:extLst xmlns:a="http://schemas.openxmlformats.org/drawingml/2006/main">
               <a:ext uri="{FF2B5EF4-FFF2-40B4-BE49-F238E27FC236}">
-                <a16:creationId xmlns:a16="http://schemas.microsoft.com/office/drawing/2014/main" id="{30CA3D76-3408-49EB-8B5C-25C24F33390D}"/>
+                <a16:creationId xmlns:a16="http://schemas.microsoft.com/office/drawing/2014/main" id="{9F7776A1-B88C-4F6D-93B2-7C2A451A1A0B}"/>
               </a:ext>
             </a:extLst>
           </p:cNvPr>
@@ -4750,7 +4750,7 @@
           <p:cNvPr id="3" name="">
             <a:extLst xmlns:a="http://schemas.openxmlformats.org/drawingml/2006/main">
               <a:ext uri="{FF2B5EF4-FFF2-40B4-BE49-F238E27FC236}">
-                <a16:creationId xmlns:a16="http://schemas.microsoft.com/office/drawing/2014/main" id="{822D1EC1-DEFA-4EC2-88BD-AC7D6D1B7CCE}"/>
+                <a16:creationId xmlns:a16="http://schemas.microsoft.com/office/drawing/2014/main" id="{097BB989-A6F0-40B1-85A6-135E422ADF30}"/>
               </a:ext>
             </a:extLst>
           </p:cNvPr>
@@ -4807,7 +4807,7 @@
           <p:cNvPr id="4" name="">
             <a:extLst xmlns:a="http://schemas.openxmlformats.org/drawingml/2006/main">
               <a:ext uri="{FF2B5EF4-FFF2-40B4-BE49-F238E27FC236}">
-                <a16:creationId xmlns:a16="http://schemas.microsoft.com/office/drawing/2014/main" id="{9935C88D-3D39-49E4-B5B4-437C56FFDB31}"/>
+                <a16:creationId xmlns:a16="http://schemas.microsoft.com/office/drawing/2014/main" id="{C20F7F32-FAE1-4C3D-B61F-6E89265C4AB1}"/>
               </a:ext>
             </a:extLst>
           </p:cNvPr>
@@ -4864,7 +4864,7 @@
           <p:cNvPr id="5" name="">
             <a:extLst xmlns:a="http://schemas.openxmlformats.org/drawingml/2006/main">
               <a:ext uri="{FF2B5EF4-FFF2-40B4-BE49-F238E27FC236}">
-                <a16:creationId xmlns:a16="http://schemas.microsoft.com/office/drawing/2014/main" id="{E6084356-22DD-47B2-92F6-D2E85B07D0B8}"/>
+                <a16:creationId xmlns:a16="http://schemas.microsoft.com/office/drawing/2014/main" id="{E9BE635C-129E-47F0-BEEC-31A057A78B88}"/>
               </a:ext>
             </a:extLst>
           </p:cNvPr>
@@ -4921,7 +4921,7 @@
           <p:cNvPr id="6" name="">
             <a:extLst xmlns:a="http://schemas.openxmlformats.org/drawingml/2006/main">
               <a:ext uri="{FF2B5EF4-FFF2-40B4-BE49-F238E27FC236}">
-                <a16:creationId xmlns:a16="http://schemas.microsoft.com/office/drawing/2014/main" id="{8192811D-6556-43EC-A0BA-134C29B7E98E}"/>
+                <a16:creationId xmlns:a16="http://schemas.microsoft.com/office/drawing/2014/main" id="{9F558750-084C-43B9-8950-7760BD3122C5}"/>
               </a:ext>
             </a:extLst>
           </p:cNvPr>
@@ -5001,7 +5001,7 @@
           <p:cNvPr id="7" name="">
             <a:extLst xmlns:a="http://schemas.openxmlformats.org/drawingml/2006/main">
               <a:ext uri="{FF2B5EF4-FFF2-40B4-BE49-F238E27FC236}">
-                <a16:creationId xmlns:a16="http://schemas.microsoft.com/office/drawing/2014/main" id="{3D2CF7C2-B3BA-4FF7-BF23-457FBE55F74B}"/>
+                <a16:creationId xmlns:a16="http://schemas.microsoft.com/office/drawing/2014/main" id="{06925DF1-5815-4946-AA4A-EADA1C979376}"/>
               </a:ext>
             </a:extLst>
           </p:cNvPr>
@@ -5058,7 +5058,7 @@
           <p:cNvPr id="8" name="">
             <a:extLst xmlns:a="http://schemas.openxmlformats.org/drawingml/2006/main">
               <a:ext uri="{FF2B5EF4-FFF2-40B4-BE49-F238E27FC236}">
-                <a16:creationId xmlns:a16="http://schemas.microsoft.com/office/drawing/2014/main" id="{B6F63ACA-FA45-42B6-9415-CB6D5D287C1B}"/>
+                <a16:creationId xmlns:a16="http://schemas.microsoft.com/office/drawing/2014/main" id="{C663029D-0890-4202-A8A8-69BC90266F44}"/>
               </a:ext>
             </a:extLst>
           </p:cNvPr>
@@ -5115,7 +5115,7 @@
           <p:cNvPr id="9" name="">
             <a:extLst xmlns:a="http://schemas.openxmlformats.org/drawingml/2006/main">
               <a:ext uri="{FF2B5EF4-FFF2-40B4-BE49-F238E27FC236}">
-                <a16:creationId xmlns:a16="http://schemas.microsoft.com/office/drawing/2014/main" id="{69AD8014-9761-4BCF-BB61-F1D3F8A1AB7B}"/>
+                <a16:creationId xmlns:a16="http://schemas.microsoft.com/office/drawing/2014/main" id="{BEC2106D-D668-44EE-9796-5000D92AA5FA}"/>
               </a:ext>
             </a:extLst>
           </p:cNvPr>
@@ -5195,7 +5195,7 @@
           <p:cNvPr id="10" name="">
             <a:extLst xmlns:a="http://schemas.openxmlformats.org/drawingml/2006/main">
               <a:ext uri="{FF2B5EF4-FFF2-40B4-BE49-F238E27FC236}">
-                <a16:creationId xmlns:a16="http://schemas.microsoft.com/office/drawing/2014/main" id="{8E4E4B4F-C4BD-41FE-BEE1-E7C0972E742A}"/>
+                <a16:creationId xmlns:a16="http://schemas.microsoft.com/office/drawing/2014/main" id="{AF034201-15AC-4855-BD0D-8DF032ED5E2A}"/>
               </a:ext>
             </a:extLst>
           </p:cNvPr>
@@ -5250,7 +5250,7 @@
     </p:spTree>
     <p:extLst>
       <p:ext uri="{BB962C8B-B14F-4D97-AF65-F5344CB8AC3E}">
-        <p14:creationId xmlns:p14="http://schemas.microsoft.com/office/powerpoint/2010/main" val="469970501"/>
+        <p14:creationId xmlns:p14="http://schemas.microsoft.com/office/powerpoint/2010/main" val="955267583"/>
       </p:ext>
     </p:extLst>
   </p:cSld>
@@ -5281,7 +5281,7 @@
           <p:cNvPr id="14" name="">
             <a:extLst xmlns:a="http://schemas.openxmlformats.org/drawingml/2006/main">
               <a:ext uri="{FF2B5EF4-FFF2-40B4-BE49-F238E27FC236}">
-                <a16:creationId xmlns:a16="http://schemas.microsoft.com/office/drawing/2014/main" id="{E5B6D777-2091-41E1-AB56-A00EBE14426B}"/>
+                <a16:creationId xmlns:a16="http://schemas.microsoft.com/office/drawing/2014/main" id="{C436E8C6-36EF-4780-975F-496DDA962629}"/>
               </a:ext>
             </a:extLst>
           </p:cNvPr>
@@ -5338,7 +5338,7 @@
           <p:cNvPr id="2" name="">
             <a:extLst xmlns:a="http://schemas.openxmlformats.org/drawingml/2006/main">
               <a:ext uri="{FF2B5EF4-FFF2-40B4-BE49-F238E27FC236}">
-                <a16:creationId xmlns:a16="http://schemas.microsoft.com/office/drawing/2014/main" id="{146D9E4E-3F24-43DE-952E-300F5ADFA5B4}"/>
+                <a16:creationId xmlns:a16="http://schemas.microsoft.com/office/drawing/2014/main" id="{254CFFBC-7338-42D5-A707-A2580ED0C40B}"/>
               </a:ext>
             </a:extLst>
           </p:cNvPr>
@@ -5395,7 +5395,7 @@
           <p:cNvPr id="3" name="">
             <a:extLst xmlns:a="http://schemas.openxmlformats.org/drawingml/2006/main">
               <a:ext uri="{FF2B5EF4-FFF2-40B4-BE49-F238E27FC236}">
-                <a16:creationId xmlns:a16="http://schemas.microsoft.com/office/drawing/2014/main" id="{D847CFEF-564B-46D7-8F36-618F3949AA12}"/>
+                <a16:creationId xmlns:a16="http://schemas.microsoft.com/office/drawing/2014/main" id="{9ECBF213-E012-4843-855B-C02558212CE3}"/>
               </a:ext>
             </a:extLst>
           </p:cNvPr>
@@ -5452,7 +5452,7 @@
           <p:cNvPr id="4" name="">
             <a:extLst xmlns:a="http://schemas.openxmlformats.org/drawingml/2006/main">
               <a:ext uri="{FF2B5EF4-FFF2-40B4-BE49-F238E27FC236}">
-                <a16:creationId xmlns:a16="http://schemas.microsoft.com/office/drawing/2014/main" id="{9E333866-CBC5-48E0-A569-0A2136871E22}"/>
+                <a16:creationId xmlns:a16="http://schemas.microsoft.com/office/drawing/2014/main" id="{06FCCD79-2B77-4F7A-A2B4-1327A7DAE459}"/>
               </a:ext>
             </a:extLst>
           </p:cNvPr>
@@ -5509,7 +5509,7 @@
           <p:cNvPr id="5" name="">
             <a:extLst xmlns:a="http://schemas.openxmlformats.org/drawingml/2006/main">
               <a:ext uri="{FF2B5EF4-FFF2-40B4-BE49-F238E27FC236}">
-                <a16:creationId xmlns:a16="http://schemas.microsoft.com/office/drawing/2014/main" id="{D356CA3F-3107-41E1-B883-6FE957B6B8CA}"/>
+                <a16:creationId xmlns:a16="http://schemas.microsoft.com/office/drawing/2014/main" id="{602887A7-894E-4457-835B-CCFC3DBB2D54}"/>
               </a:ext>
             </a:extLst>
           </p:cNvPr>
@@ -5566,7 +5566,7 @@
           <p:cNvPr id="6" name="">
             <a:extLst xmlns:a="http://schemas.openxmlformats.org/drawingml/2006/main">
               <a:ext uri="{FF2B5EF4-FFF2-40B4-BE49-F238E27FC236}">
-                <a16:creationId xmlns:a16="http://schemas.microsoft.com/office/drawing/2014/main" id="{984B90ED-B3FB-41BA-A6A0-00F34CE2DB12}"/>
+                <a16:creationId xmlns:a16="http://schemas.microsoft.com/office/drawing/2014/main" id="{2E60FDB9-AEC0-401B-B873-16788865C212}"/>
               </a:ext>
             </a:extLst>
           </p:cNvPr>
@@ -5692,7 +5692,7 @@
           <p:cNvPr id="7" name="">
             <a:extLst xmlns:a="http://schemas.openxmlformats.org/drawingml/2006/main">
               <a:ext uri="{FF2B5EF4-FFF2-40B4-BE49-F238E27FC236}">
-                <a16:creationId xmlns:a16="http://schemas.microsoft.com/office/drawing/2014/main" id="{2D6BCC18-F52B-4C20-BBC6-41B97A405490}"/>
+                <a16:creationId xmlns:a16="http://schemas.microsoft.com/office/drawing/2014/main" id="{4B77F0EF-AEC4-494A-99C1-B8392833BEC1}"/>
               </a:ext>
             </a:extLst>
           </p:cNvPr>
@@ -5749,7 +5749,7 @@
           <p:cNvPr id="8" name="">
             <a:extLst xmlns:a="http://schemas.openxmlformats.org/drawingml/2006/main">
               <a:ext uri="{FF2B5EF4-FFF2-40B4-BE49-F238E27FC236}">
-                <a16:creationId xmlns:a16="http://schemas.microsoft.com/office/drawing/2014/main" id="{3A95EF4F-4B61-412B-8A35-74E3B65247DC}"/>
+                <a16:creationId xmlns:a16="http://schemas.microsoft.com/office/drawing/2014/main" id="{C1E2E535-A01F-4B8A-8D18-B0A93639D1A6}"/>
               </a:ext>
             </a:extLst>
           </p:cNvPr>
@@ -5806,7 +5806,7 @@
           <p:cNvPr id="9" name="">
             <a:extLst xmlns:a="http://schemas.openxmlformats.org/drawingml/2006/main">
               <a:ext uri="{FF2B5EF4-FFF2-40B4-BE49-F238E27FC236}">
-                <a16:creationId xmlns:a16="http://schemas.microsoft.com/office/drawing/2014/main" id="{DEF6E431-C9EC-4F28-8653-76584FC06562}"/>
+                <a16:creationId xmlns:a16="http://schemas.microsoft.com/office/drawing/2014/main" id="{853121F2-DE3B-4FEF-82F6-9B88D86C2B49}"/>
               </a:ext>
             </a:extLst>
           </p:cNvPr>
@@ -5932,7 +5932,7 @@
           <p:cNvPr id="10" name="">
             <a:extLst xmlns:a="http://schemas.openxmlformats.org/drawingml/2006/main">
               <a:ext uri="{FF2B5EF4-FFF2-40B4-BE49-F238E27FC236}">
-                <a16:creationId xmlns:a16="http://schemas.microsoft.com/office/drawing/2014/main" id="{FB031DCE-7916-466A-A153-FA9A7F3E2B18}"/>
+                <a16:creationId xmlns:a16="http://schemas.microsoft.com/office/drawing/2014/main" id="{D0044F84-BA0C-417B-90A1-40F881D9A308}"/>
               </a:ext>
             </a:extLst>
           </p:cNvPr>
@@ -5989,7 +5989,7 @@
           <p:cNvPr id="11" name="">
             <a:extLst xmlns:a="http://schemas.openxmlformats.org/drawingml/2006/main">
               <a:ext uri="{FF2B5EF4-FFF2-40B4-BE49-F238E27FC236}">
-                <a16:creationId xmlns:a16="http://schemas.microsoft.com/office/drawing/2014/main" id="{C1FD93A1-C723-4001-88F9-D805451BA5E6}"/>
+                <a16:creationId xmlns:a16="http://schemas.microsoft.com/office/drawing/2014/main" id="{58C88CEA-447F-4E89-994F-136C80871DBB}"/>
               </a:ext>
             </a:extLst>
           </p:cNvPr>
@@ -6046,7 +6046,7 @@
           <p:cNvPr id="12" name="">
             <a:extLst xmlns:a="http://schemas.openxmlformats.org/drawingml/2006/main">
               <a:ext uri="{FF2B5EF4-FFF2-40B4-BE49-F238E27FC236}">
-                <a16:creationId xmlns:a16="http://schemas.microsoft.com/office/drawing/2014/main" id="{DB2D7686-333F-4FD0-9BA1-E4A240107925}"/>
+                <a16:creationId xmlns:a16="http://schemas.microsoft.com/office/drawing/2014/main" id="{463F882B-F865-428C-8F60-4ED38BDB697B}"/>
               </a:ext>
             </a:extLst>
           </p:cNvPr>
@@ -6172,7 +6172,7 @@
           <p:cNvPr id="13" name="">
             <a:extLst xmlns:a="http://schemas.openxmlformats.org/drawingml/2006/main">
               <a:ext uri="{FF2B5EF4-FFF2-40B4-BE49-F238E27FC236}">
-                <a16:creationId xmlns:a16="http://schemas.microsoft.com/office/drawing/2014/main" id="{2FD79ED0-53A5-4D41-9DD9-7D446B8CC038}"/>
+                <a16:creationId xmlns:a16="http://schemas.microsoft.com/office/drawing/2014/main" id="{11F82B91-B6A7-43A2-AC1B-FE93F8C8924B}"/>
               </a:ext>
             </a:extLst>
           </p:cNvPr>
@@ -6227,7 +6227,7 @@
     </p:spTree>
     <p:extLst>
       <p:ext uri="{BB962C8B-B14F-4D97-AF65-F5344CB8AC3E}">
-        <p14:creationId xmlns:p14="http://schemas.microsoft.com/office/powerpoint/2010/main" val="76308210"/>
+        <p14:creationId xmlns:p14="http://schemas.microsoft.com/office/powerpoint/2010/main" val="1995717022"/>
       </p:ext>
     </p:extLst>
   </p:cSld>
@@ -6255,10 +6255,10 @@
       </p:grpSpPr>
       <p:sp>
         <p:nvSpPr>
-          <p:cNvPr id="6" name="">
+          <p:cNvPr id="7" name="">
             <a:extLst xmlns:a="http://schemas.openxmlformats.org/drawingml/2006/main">
               <a:ext uri="{FF2B5EF4-FFF2-40B4-BE49-F238E27FC236}">
-                <a16:creationId xmlns:a16="http://schemas.microsoft.com/office/drawing/2014/main" id="{47EF45B1-7B1C-44F9-A6EC-01A1C5EEFA7E}"/>
+                <a16:creationId xmlns:a16="http://schemas.microsoft.com/office/drawing/2014/main" id="{B5357716-DE0C-473F-8DFD-D52A5D3439BA}"/>
               </a:ext>
             </a:extLst>
           </p:cNvPr>
@@ -6315,7 +6315,7 @@
           <p:cNvPr id="2" name="">
             <a:extLst xmlns:a="http://schemas.openxmlformats.org/drawingml/2006/main">
               <a:ext uri="{FF2B5EF4-FFF2-40B4-BE49-F238E27FC236}">
-                <a16:creationId xmlns:a16="http://schemas.microsoft.com/office/drawing/2014/main" id="{68C81CDF-EE7F-463E-91AA-DE39A442F25B}"/>
+                <a16:creationId xmlns:a16="http://schemas.microsoft.com/office/drawing/2014/main" id="{DD879375-1D9D-4A40-8C25-FA0AFBE40D16}"/>
               </a:ext>
             </a:extLst>
           </p:cNvPr>
@@ -6372,7 +6372,7 @@
           <p:cNvPr id="3" name="">
             <a:extLst xmlns:a="http://schemas.openxmlformats.org/drawingml/2006/main">
               <a:ext uri="{FF2B5EF4-FFF2-40B4-BE49-F238E27FC236}">
-                <a16:creationId xmlns:a16="http://schemas.microsoft.com/office/drawing/2014/main" id="{8DC3E19A-6131-4657-85CE-23D0AB0D796C}"/>
+                <a16:creationId xmlns:a16="http://schemas.microsoft.com/office/drawing/2014/main" id="{F900A225-9B60-4CBD-B496-B63A53E8DACA}"/>
               </a:ext>
             </a:extLst>
           </p:cNvPr>
@@ -6452,7 +6452,7 @@
           <p:cNvPr id="4" name="">
             <a:extLst xmlns:a="http://schemas.openxmlformats.org/drawingml/2006/main">
               <a:ext uri="{FF2B5EF4-FFF2-40B4-BE49-F238E27FC236}">
-                <a16:creationId xmlns:a16="http://schemas.microsoft.com/office/drawing/2014/main" id="{98C51F26-E0F5-4AE9-8F1D-63495D69B7FF}"/>
+                <a16:creationId xmlns:a16="http://schemas.microsoft.com/office/drawing/2014/main" id="{90A9C9B9-AFF1-46C3-90FE-5A0F897E55A3}"/>
               </a:ext>
             </a:extLst>
           </p:cNvPr>
@@ -6509,7 +6509,7 @@
           <p:cNvPr id="5" name="">
             <a:extLst xmlns:a="http://schemas.openxmlformats.org/drawingml/2006/main">
               <a:ext uri="{FF2B5EF4-FFF2-40B4-BE49-F238E27FC236}">
-                <a16:creationId xmlns:a16="http://schemas.microsoft.com/office/drawing/2014/main" id="{15D26722-7C23-457A-9778-EB73F2EA9A60}"/>
+                <a16:creationId xmlns:a16="http://schemas.microsoft.com/office/drawing/2014/main" id="{3331B4C2-5D24-4D2F-B3AD-8A0E378EF260}"/>
               </a:ext>
             </a:extLst>
           </p:cNvPr>
@@ -6520,8 +6520,8 @@
         </p:nvSpPr>
         <p:spPr>
           <a:xfrm xmlns:a="http://schemas.openxmlformats.org/drawingml/2006/main">
-            <a:off x="609600" y="4733925"/>
-            <a:ext cx="10668000" cy="895350"/>
+            <a:off x="609600" y="4610100"/>
+            <a:ext cx="10668000" cy="838200"/>
           </a:xfrm>
           <a:prstGeom xmlns:a="http://schemas.openxmlformats.org/drawingml/2006/main" prst="rect">
             <a:avLst/>
@@ -6538,7 +6538,7 @@
           <a:lstStyle xmlns:a="http://schemas.openxmlformats.org/drawingml/2006/main"/>
           <a:p xmlns:a="http://schemas.openxmlformats.org/drawingml/2006/main">
             <a:pPr>
-              <a:defRPr sz="2250" b="0">
+              <a:defRPr sz="2100" b="0">
                 <a:solidFill>
                   <a:srgbClr val="FFFFFF"/>
                 </a:solidFill>
@@ -6548,7 +6548,7 @@
               </a:defRPr>
             </a:pPr>
             <a:r>
-              <a:rPr sz="2250" b="0">
+              <a:rPr sz="2100" b="0">
                 <a:solidFill>
                   <a:srgbClr val="FFFFFF"/>
                 </a:solidFill>
@@ -6561,7 +6561,7 @@
           </a:p>
           <a:p xmlns:a="http://schemas.openxmlformats.org/drawingml/2006/main">
             <a:pPr>
-              <a:defRPr sz="2250" b="0">
+              <a:defRPr sz="2100" b="0">
                 <a:solidFill>
                   <a:srgbClr val="FFFFFF"/>
                 </a:solidFill>
@@ -6571,7 +6571,7 @@
               </a:defRPr>
             </a:pPr>
             <a:r>
-              <a:rPr sz="2250" b="0">
+              <a:rPr sz="2100" b="0">
                 <a:solidFill>
                   <a:srgbClr val="FFFFFF"/>
                 </a:solidFill>
@@ -6580,6 +6580,63 @@
                 <a:cs typeface="Helvetica Neue"/>
               </a:rPr>
               <a:t>We test the inputs, planning value and repeat use.</a:t>
+            </a:r>
+          </a:p>
+        </p:txBody>
+      </p:sp>
+      <p:sp>
+        <p:nvSpPr>
+          <p:cNvPr id="6" name="">
+            <a:extLst xmlns:a="http://schemas.openxmlformats.org/drawingml/2006/main">
+              <a:ext uri="{FF2B5EF4-FFF2-40B4-BE49-F238E27FC236}">
+                <a16:creationId xmlns:a16="http://schemas.microsoft.com/office/drawing/2014/main" id="{2E2FD52A-8C71-467D-9896-5E15F977F1DD}"/>
+              </a:ext>
+            </a:extLst>
+          </p:cNvPr>
+          <p:cNvSpPr>
+            <a:spLocks xmlns:a="http://schemas.openxmlformats.org/drawingml/2006/main" noGrp="1"/>
+          </p:cNvSpPr>
+          <p:nvPr/>
+        </p:nvSpPr>
+        <p:spPr>
+          <a:xfrm xmlns:a="http://schemas.openxmlformats.org/drawingml/2006/main">
+            <a:off x="609600" y="5743575"/>
+            <a:ext cx="10572750" cy="409575"/>
+          </a:xfrm>
+          <a:prstGeom xmlns:a="http://schemas.openxmlformats.org/drawingml/2006/main" prst="rect">
+            <a:avLst/>
+          </a:prstGeom>
+          <a:noFill xmlns:a="http://schemas.openxmlformats.org/drawingml/2006/main"/>
+          <a:ln xmlns:a="http://schemas.openxmlformats.org/drawingml/2006/main" w="0">
+            <a:noFill/>
+          </a:ln>
+        </p:spPr>
+        <p:txBody>
+          <a:bodyPr xmlns:a="http://schemas.openxmlformats.org/drawingml/2006/main">
+            <a:noAutofit/>
+          </a:bodyPr>
+          <a:lstStyle xmlns:a="http://schemas.openxmlformats.org/drawingml/2006/main"/>
+          <a:p xmlns:a="http://schemas.openxmlformats.org/drawingml/2006/main">
+            <a:pPr>
+              <a:defRPr sz="2250" b="1">
+                <a:solidFill>
+                  <a:srgbClr val="D1F36D"/>
+                </a:solidFill>
+                <a:latin typeface="Helvetica Neue"/>
+                <a:ea typeface="Helvetica Neue"/>
+                <a:cs typeface="Helvetica Neue"/>
+              </a:defRPr>
+            </a:pPr>
+            <a:r>
+              <a:rPr sz="2250" b="1">
+                <a:solidFill>
+                  <a:srgbClr val="D1F36D"/>
+                </a:solidFill>
+                <a:latin typeface="Helvetica Neue"/>
+                <a:ea typeface="Helvetica Neue"/>
+                <a:cs typeface="Helvetica Neue"/>
+              </a:rPr>
+              <a:t>shadeshift-city.web.app</a:t>
             </a:r>
           </a:p>
         </p:txBody>
@@ -6587,7 +6644,7 @@
     </p:spTree>
     <p:extLst>
       <p:ext uri="{BB962C8B-B14F-4D97-AF65-F5344CB8AC3E}">
-        <p14:creationId xmlns:p14="http://schemas.microsoft.com/office/powerpoint/2010/main" val="2139040718"/>
+        <p14:creationId xmlns:p14="http://schemas.microsoft.com/office/powerpoint/2010/main" val="586663129"/>
       </p:ext>
     </p:extLst>
   </p:cSld>

</xml_diff>